<commit_message>
Document HW in loop - FieldVision
</commit_message>
<xml_diff>
--- a/docs/MonarchVision Images.pptx
+++ b/docs/MonarchVision Images.pptx
@@ -6,6 +6,8 @@
   </p:sldMasterIdLst>
   <p:sldIdLst>
     <p:sldId id="256" r:id="rId2"/>
+    <p:sldId id="257" r:id="rId3"/>
+    <p:sldId id="258" r:id="rId4"/>
   </p:sldIdLst>
   <p:sldSz cx="12192000" cy="6858000"/>
   <p:notesSz cx="6858000" cy="9144000"/>
@@ -270,7 +272,7 @@
           <a:p>
             <a:fld id="{4D551878-E37B-4750-806A-2AF402944E90}" type="datetimeFigureOut">
               <a:rPr lang="en-US" smtClean="0"/>
-              <a:t>8/17/2026</a:t>
+              <a:t>8/18/2026</a:t>
             </a:fld>
             <a:endParaRPr lang="en-US"/>
           </a:p>
@@ -468,7 +470,7 @@
           <a:p>
             <a:fld id="{4D551878-E37B-4750-806A-2AF402944E90}" type="datetimeFigureOut">
               <a:rPr lang="en-US" smtClean="0"/>
-              <a:t>8/17/2026</a:t>
+              <a:t>8/18/2026</a:t>
             </a:fld>
             <a:endParaRPr lang="en-US"/>
           </a:p>
@@ -676,7 +678,7 @@
           <a:p>
             <a:fld id="{4D551878-E37B-4750-806A-2AF402944E90}" type="datetimeFigureOut">
               <a:rPr lang="en-US" smtClean="0"/>
-              <a:t>8/17/2026</a:t>
+              <a:t>8/18/2026</a:t>
             </a:fld>
             <a:endParaRPr lang="en-US"/>
           </a:p>
@@ -874,7 +876,7 @@
           <a:p>
             <a:fld id="{4D551878-E37B-4750-806A-2AF402944E90}" type="datetimeFigureOut">
               <a:rPr lang="en-US" smtClean="0"/>
-              <a:t>8/17/2026</a:t>
+              <a:t>8/18/2026</a:t>
             </a:fld>
             <a:endParaRPr lang="en-US"/>
           </a:p>
@@ -1149,7 +1151,7 @@
           <a:p>
             <a:fld id="{4D551878-E37B-4750-806A-2AF402944E90}" type="datetimeFigureOut">
               <a:rPr lang="en-US" smtClean="0"/>
-              <a:t>8/17/2026</a:t>
+              <a:t>8/18/2026</a:t>
             </a:fld>
             <a:endParaRPr lang="en-US"/>
           </a:p>
@@ -1414,7 +1416,7 @@
           <a:p>
             <a:fld id="{4D551878-E37B-4750-806A-2AF402944E90}" type="datetimeFigureOut">
               <a:rPr lang="en-US" smtClean="0"/>
-              <a:t>8/17/2026</a:t>
+              <a:t>8/18/2026</a:t>
             </a:fld>
             <a:endParaRPr lang="en-US"/>
           </a:p>
@@ -1826,7 +1828,7 @@
           <a:p>
             <a:fld id="{4D551878-E37B-4750-806A-2AF402944E90}" type="datetimeFigureOut">
               <a:rPr lang="en-US" smtClean="0"/>
-              <a:t>8/17/2026</a:t>
+              <a:t>8/18/2026</a:t>
             </a:fld>
             <a:endParaRPr lang="en-US"/>
           </a:p>
@@ -1967,7 +1969,7 @@
           <a:p>
             <a:fld id="{4D551878-E37B-4750-806A-2AF402944E90}" type="datetimeFigureOut">
               <a:rPr lang="en-US" smtClean="0"/>
-              <a:t>8/17/2026</a:t>
+              <a:t>8/18/2026</a:t>
             </a:fld>
             <a:endParaRPr lang="en-US"/>
           </a:p>
@@ -2080,7 +2082,7 @@
           <a:p>
             <a:fld id="{4D551878-E37B-4750-806A-2AF402944E90}" type="datetimeFigureOut">
               <a:rPr lang="en-US" smtClean="0"/>
-              <a:t>8/17/2026</a:t>
+              <a:t>8/18/2026</a:t>
             </a:fld>
             <a:endParaRPr lang="en-US"/>
           </a:p>
@@ -2391,7 +2393,7 @@
           <a:p>
             <a:fld id="{4D551878-E37B-4750-806A-2AF402944E90}" type="datetimeFigureOut">
               <a:rPr lang="en-US" smtClean="0"/>
-              <a:t>8/17/2026</a:t>
+              <a:t>8/18/2026</a:t>
             </a:fld>
             <a:endParaRPr lang="en-US"/>
           </a:p>
@@ -2679,7 +2681,7 @@
           <a:p>
             <a:fld id="{4D551878-E37B-4750-806A-2AF402944E90}" type="datetimeFigureOut">
               <a:rPr lang="en-US" smtClean="0"/>
-              <a:t>8/17/2026</a:t>
+              <a:t>8/18/2026</a:t>
             </a:fld>
             <a:endParaRPr lang="en-US"/>
           </a:p>
@@ -2920,7 +2922,7 @@
           <a:p>
             <a:fld id="{4D551878-E37B-4750-806A-2AF402944E90}" type="datetimeFigureOut">
               <a:rPr lang="en-US" smtClean="0"/>
-              <a:t>8/17/2026</a:t>
+              <a:t>8/18/2026</a:t>
             </a:fld>
             <a:endParaRPr lang="en-US"/>
           </a:p>
@@ -3947,6 +3949,228 @@
 </p:sld>
 </file>
 
+<file path=ppt/slides/slide2.xml><?xml version="1.0" encoding="utf-8"?>
+<p:sld xmlns:a="http://schemas.openxmlformats.org/drawingml/2006/main" xmlns:r="http://schemas.openxmlformats.org/officeDocument/2006/relationships" xmlns:p="http://schemas.openxmlformats.org/presentationml/2006/main">
+  <p:cSld>
+    <p:spTree>
+      <p:nvGrpSpPr>
+        <p:cNvPr id="1" name=""/>
+        <p:cNvGrpSpPr/>
+        <p:nvPr/>
+      </p:nvGrpSpPr>
+      <p:grpSpPr>
+        <a:xfrm>
+          <a:off x="0" y="0"/>
+          <a:ext cx="0" cy="0"/>
+          <a:chOff x="0" y="0"/>
+          <a:chExt cx="0" cy="0"/>
+        </a:xfrm>
+      </p:grpSpPr>
+      <p:pic>
+        <p:nvPicPr>
+          <p:cNvPr id="5" name="Picture 4">
+            <a:extLst>
+              <a:ext uri="{FF2B5EF4-FFF2-40B4-BE49-F238E27FC236}">
+                <a16:creationId xmlns:a16="http://schemas.microsoft.com/office/drawing/2014/main" id="{3D214790-C1E3-7D6A-B397-2029E7DE4538}"/>
+              </a:ext>
+            </a:extLst>
+          </p:cNvPr>
+          <p:cNvPicPr>
+            <a:picLocks noChangeAspect="1"/>
+          </p:cNvPicPr>
+          <p:nvPr/>
+        </p:nvPicPr>
+        <p:blipFill>
+          <a:blip r:embed="rId2">
+            <a:extLst>
+              <a:ext uri="{28A0092B-C50C-407E-A947-70E740481C1C}">
+                <a14:useLocalDpi xmlns:a14="http://schemas.microsoft.com/office/drawing/2010/main" val="0"/>
+              </a:ext>
+            </a:extLst>
+          </a:blip>
+          <a:srcRect l="1287" r="5011" b="18777"/>
+          <a:stretch>
+            <a:fillRect/>
+          </a:stretch>
+        </p:blipFill>
+        <p:spPr>
+          <a:xfrm rot="5400000">
+            <a:off x="501431" y="1406513"/>
+            <a:ext cx="6381885" cy="4149032"/>
+          </a:xfrm>
+          <a:prstGeom prst="rect">
+            <a:avLst/>
+          </a:prstGeom>
+        </p:spPr>
+      </p:pic>
+      <p:pic>
+        <p:nvPicPr>
+          <p:cNvPr id="7" name="Picture 6">
+            <a:extLst>
+              <a:ext uri="{FF2B5EF4-FFF2-40B4-BE49-F238E27FC236}">
+                <a16:creationId xmlns:a16="http://schemas.microsoft.com/office/drawing/2014/main" id="{BFA84F73-BD42-E235-6E86-B64A4FD5E9D2}"/>
+              </a:ext>
+            </a:extLst>
+          </p:cNvPr>
+          <p:cNvPicPr>
+            <a:picLocks noChangeAspect="1"/>
+          </p:cNvPicPr>
+          <p:nvPr/>
+        </p:nvPicPr>
+        <p:blipFill>
+          <a:blip r:embed="rId3">
+            <a:extLst>
+              <a:ext uri="{28A0092B-C50C-407E-A947-70E740481C1C}">
+                <a14:useLocalDpi xmlns:a14="http://schemas.microsoft.com/office/drawing/2010/main" val="0"/>
+              </a:ext>
+            </a:extLst>
+          </a:blip>
+          <a:stretch>
+            <a:fillRect/>
+          </a:stretch>
+        </p:blipFill>
+        <p:spPr>
+          <a:xfrm>
+            <a:off x="6337738" y="290086"/>
+            <a:ext cx="4660169" cy="6377738"/>
+          </a:xfrm>
+          <a:prstGeom prst="rect">
+            <a:avLst/>
+          </a:prstGeom>
+          <a:ln>
+            <a:solidFill>
+              <a:schemeClr val="tx1"/>
+            </a:solidFill>
+          </a:ln>
+        </p:spPr>
+      </p:pic>
+    </p:spTree>
+    <p:extLst>
+      <p:ext uri="{BB962C8B-B14F-4D97-AF65-F5344CB8AC3E}">
+        <p14:creationId xmlns:p14="http://schemas.microsoft.com/office/powerpoint/2010/main" val="2369680745"/>
+      </p:ext>
+    </p:extLst>
+  </p:cSld>
+  <p:clrMapOvr>
+    <a:masterClrMapping/>
+  </p:clrMapOvr>
+</p:sld>
+</file>
+
+<file path=ppt/slides/slide3.xml><?xml version="1.0" encoding="utf-8"?>
+<p:sld xmlns:a="http://schemas.openxmlformats.org/drawingml/2006/main" xmlns:r="http://schemas.openxmlformats.org/officeDocument/2006/relationships" xmlns:p="http://schemas.openxmlformats.org/presentationml/2006/main">
+  <p:cSld>
+    <p:spTree>
+      <p:nvGrpSpPr>
+        <p:cNvPr id="1" name="">
+          <a:extLst>
+            <a:ext uri="{FF2B5EF4-FFF2-40B4-BE49-F238E27FC236}">
+              <a16:creationId xmlns:a16="http://schemas.microsoft.com/office/drawing/2014/main" id="{B09EE7E5-DD79-B64A-8565-AA757041A669}"/>
+            </a:ext>
+          </a:extLst>
+        </p:cNvPr>
+        <p:cNvGrpSpPr/>
+        <p:nvPr/>
+      </p:nvGrpSpPr>
+      <p:grpSpPr>
+        <a:xfrm>
+          <a:off x="0" y="0"/>
+          <a:ext cx="0" cy="0"/>
+          <a:chOff x="0" y="0"/>
+          <a:chExt cx="0" cy="0"/>
+        </a:xfrm>
+      </p:grpSpPr>
+      <p:pic>
+        <p:nvPicPr>
+          <p:cNvPr id="3" name="Picture 2">
+            <a:extLst>
+              <a:ext uri="{FF2B5EF4-FFF2-40B4-BE49-F238E27FC236}">
+                <a16:creationId xmlns:a16="http://schemas.microsoft.com/office/drawing/2014/main" id="{945C78E0-ED38-ED47-0C04-8E5147155F72}"/>
+              </a:ext>
+            </a:extLst>
+          </p:cNvPr>
+          <p:cNvPicPr>
+            <a:picLocks noChangeAspect="1"/>
+          </p:cNvPicPr>
+          <p:nvPr/>
+        </p:nvPicPr>
+        <p:blipFill>
+          <a:blip r:embed="rId2">
+            <a:extLst>
+              <a:ext uri="{28A0092B-C50C-407E-A947-70E740481C1C}">
+                <a14:useLocalDpi xmlns:a14="http://schemas.microsoft.com/office/drawing/2010/main" val="0"/>
+              </a:ext>
+            </a:extLst>
+          </a:blip>
+          <a:srcRect t="4436" r="9216"/>
+          <a:stretch>
+            <a:fillRect/>
+          </a:stretch>
+        </p:blipFill>
+        <p:spPr>
+          <a:xfrm>
+            <a:off x="2176199" y="284328"/>
+            <a:ext cx="3411100" cy="6383497"/>
+          </a:xfrm>
+          <a:prstGeom prst="rect">
+            <a:avLst/>
+          </a:prstGeom>
+        </p:spPr>
+      </p:pic>
+      <p:pic>
+        <p:nvPicPr>
+          <p:cNvPr id="4" name="Picture 3">
+            <a:extLst>
+              <a:ext uri="{FF2B5EF4-FFF2-40B4-BE49-F238E27FC236}">
+                <a16:creationId xmlns:a16="http://schemas.microsoft.com/office/drawing/2014/main" id="{D9550E14-74AC-287F-44E5-0834F602F8FD}"/>
+              </a:ext>
+            </a:extLst>
+          </p:cNvPr>
+          <p:cNvPicPr>
+            <a:picLocks noChangeAspect="1"/>
+          </p:cNvPicPr>
+          <p:nvPr/>
+        </p:nvPicPr>
+        <p:blipFill>
+          <a:blip r:embed="rId3">
+            <a:extLst>
+              <a:ext uri="{28A0092B-C50C-407E-A947-70E740481C1C}">
+                <a14:useLocalDpi xmlns:a14="http://schemas.microsoft.com/office/drawing/2010/main" val="0"/>
+              </a:ext>
+            </a:extLst>
+          </a:blip>
+          <a:stretch>
+            <a:fillRect/>
+          </a:stretch>
+        </p:blipFill>
+        <p:spPr>
+          <a:xfrm>
+            <a:off x="6353503" y="288709"/>
+            <a:ext cx="4711704" cy="6379116"/>
+          </a:xfrm>
+          <a:prstGeom prst="rect">
+            <a:avLst/>
+          </a:prstGeom>
+          <a:ln>
+            <a:solidFill>
+              <a:schemeClr val="tx1"/>
+            </a:solidFill>
+          </a:ln>
+        </p:spPr>
+      </p:pic>
+    </p:spTree>
+    <p:extLst>
+      <p:ext uri="{BB962C8B-B14F-4D97-AF65-F5344CB8AC3E}">
+        <p14:creationId xmlns:p14="http://schemas.microsoft.com/office/powerpoint/2010/main" val="1120302383"/>
+      </p:ext>
+    </p:extLst>
+  </p:cSld>
+  <p:clrMapOvr>
+    <a:masterClrMapping/>
+  </p:clrMapOvr>
+</p:sld>
+</file>
+
 <file path=ppt/theme/theme1.xml><?xml version="1.0" encoding="utf-8"?>
 <a:theme xmlns:a="http://schemas.openxmlformats.org/drawingml/2006/main" name="Office Theme">
   <a:themeElements>

</xml_diff>

<commit_message>
Document HW in loop - Object Vision
</commit_message>
<xml_diff>
--- a/docs/MonarchVision Images.pptx
+++ b/docs/MonarchVision Images.pptx
@@ -8,6 +8,7 @@
     <p:sldId id="256" r:id="rId2"/>
     <p:sldId id="257" r:id="rId3"/>
     <p:sldId id="258" r:id="rId4"/>
+    <p:sldId id="259" r:id="rId5"/>
   </p:sldIdLst>
   <p:sldSz cx="12192000" cy="6858000"/>
   <p:notesSz cx="6858000" cy="9144000"/>
@@ -272,7 +273,7 @@
           <a:p>
             <a:fld id="{4D551878-E37B-4750-806A-2AF402944E90}" type="datetimeFigureOut">
               <a:rPr lang="en-US" smtClean="0"/>
-              <a:t>8/18/2026</a:t>
+              <a:t>8/19/2026</a:t>
             </a:fld>
             <a:endParaRPr lang="en-US"/>
           </a:p>
@@ -470,7 +471,7 @@
           <a:p>
             <a:fld id="{4D551878-E37B-4750-806A-2AF402944E90}" type="datetimeFigureOut">
               <a:rPr lang="en-US" smtClean="0"/>
-              <a:t>8/18/2026</a:t>
+              <a:t>8/19/2026</a:t>
             </a:fld>
             <a:endParaRPr lang="en-US"/>
           </a:p>
@@ -678,7 +679,7 @@
           <a:p>
             <a:fld id="{4D551878-E37B-4750-806A-2AF402944E90}" type="datetimeFigureOut">
               <a:rPr lang="en-US" smtClean="0"/>
-              <a:t>8/18/2026</a:t>
+              <a:t>8/19/2026</a:t>
             </a:fld>
             <a:endParaRPr lang="en-US"/>
           </a:p>
@@ -876,7 +877,7 @@
           <a:p>
             <a:fld id="{4D551878-E37B-4750-806A-2AF402944E90}" type="datetimeFigureOut">
               <a:rPr lang="en-US" smtClean="0"/>
-              <a:t>8/18/2026</a:t>
+              <a:t>8/19/2026</a:t>
             </a:fld>
             <a:endParaRPr lang="en-US"/>
           </a:p>
@@ -1151,7 +1152,7 @@
           <a:p>
             <a:fld id="{4D551878-E37B-4750-806A-2AF402944E90}" type="datetimeFigureOut">
               <a:rPr lang="en-US" smtClean="0"/>
-              <a:t>8/18/2026</a:t>
+              <a:t>8/19/2026</a:t>
             </a:fld>
             <a:endParaRPr lang="en-US"/>
           </a:p>
@@ -1416,7 +1417,7 @@
           <a:p>
             <a:fld id="{4D551878-E37B-4750-806A-2AF402944E90}" type="datetimeFigureOut">
               <a:rPr lang="en-US" smtClean="0"/>
-              <a:t>8/18/2026</a:t>
+              <a:t>8/19/2026</a:t>
             </a:fld>
             <a:endParaRPr lang="en-US"/>
           </a:p>
@@ -1828,7 +1829,7 @@
           <a:p>
             <a:fld id="{4D551878-E37B-4750-806A-2AF402944E90}" type="datetimeFigureOut">
               <a:rPr lang="en-US" smtClean="0"/>
-              <a:t>8/18/2026</a:t>
+              <a:t>8/19/2026</a:t>
             </a:fld>
             <a:endParaRPr lang="en-US"/>
           </a:p>
@@ -1969,7 +1970,7 @@
           <a:p>
             <a:fld id="{4D551878-E37B-4750-806A-2AF402944E90}" type="datetimeFigureOut">
               <a:rPr lang="en-US" smtClean="0"/>
-              <a:t>8/18/2026</a:t>
+              <a:t>8/19/2026</a:t>
             </a:fld>
             <a:endParaRPr lang="en-US"/>
           </a:p>
@@ -2082,7 +2083,7 @@
           <a:p>
             <a:fld id="{4D551878-E37B-4750-806A-2AF402944E90}" type="datetimeFigureOut">
               <a:rPr lang="en-US" smtClean="0"/>
-              <a:t>8/18/2026</a:t>
+              <a:t>8/19/2026</a:t>
             </a:fld>
             <a:endParaRPr lang="en-US"/>
           </a:p>
@@ -2393,7 +2394,7 @@
           <a:p>
             <a:fld id="{4D551878-E37B-4750-806A-2AF402944E90}" type="datetimeFigureOut">
               <a:rPr lang="en-US" smtClean="0"/>
-              <a:t>8/18/2026</a:t>
+              <a:t>8/19/2026</a:t>
             </a:fld>
             <a:endParaRPr lang="en-US"/>
           </a:p>
@@ -2681,7 +2682,7 @@
           <a:p>
             <a:fld id="{4D551878-E37B-4750-806A-2AF402944E90}" type="datetimeFigureOut">
               <a:rPr lang="en-US" smtClean="0"/>
-              <a:t>8/18/2026</a:t>
+              <a:t>8/19/2026</a:t>
             </a:fld>
             <a:endParaRPr lang="en-US"/>
           </a:p>
@@ -2922,7 +2923,7 @@
           <a:p>
             <a:fld id="{4D551878-E37B-4750-806A-2AF402944E90}" type="datetimeFigureOut">
               <a:rPr lang="en-US" smtClean="0"/>
-              <a:t>8/18/2026</a:t>
+              <a:t>8/19/2026</a:t>
             </a:fld>
             <a:endParaRPr lang="en-US"/>
           </a:p>
@@ -4171,6 +4172,211 @@
 </p:sld>
 </file>
 
+<file path=ppt/slides/slide4.xml><?xml version="1.0" encoding="utf-8"?>
+<p:sld xmlns:a="http://schemas.openxmlformats.org/drawingml/2006/main" xmlns:r="http://schemas.openxmlformats.org/officeDocument/2006/relationships" xmlns:p="http://schemas.openxmlformats.org/presentationml/2006/main">
+  <p:cSld>
+    <p:spTree>
+      <p:nvGrpSpPr>
+        <p:cNvPr id="1" name="">
+          <a:extLst>
+            <a:ext uri="{FF2B5EF4-FFF2-40B4-BE49-F238E27FC236}">
+              <a16:creationId xmlns:a16="http://schemas.microsoft.com/office/drawing/2014/main" id="{5A1DC8DE-5E6D-8A28-C136-4D64872A628F}"/>
+            </a:ext>
+          </a:extLst>
+        </p:cNvPr>
+        <p:cNvGrpSpPr/>
+        <p:nvPr/>
+      </p:nvGrpSpPr>
+      <p:grpSpPr>
+        <a:xfrm>
+          <a:off x="0" y="0"/>
+          <a:ext cx="0" cy="0"/>
+          <a:chOff x="0" y="0"/>
+          <a:chExt cx="0" cy="0"/>
+        </a:xfrm>
+      </p:grpSpPr>
+      <p:pic>
+        <p:nvPicPr>
+          <p:cNvPr id="7" name="Picture 6">
+            <a:extLst>
+              <a:ext uri="{FF2B5EF4-FFF2-40B4-BE49-F238E27FC236}">
+                <a16:creationId xmlns:a16="http://schemas.microsoft.com/office/drawing/2014/main" id="{541AC46A-EB03-D87F-2498-65D0F8C92C12}"/>
+              </a:ext>
+            </a:extLst>
+          </p:cNvPr>
+          <p:cNvPicPr>
+            <a:picLocks noChangeAspect="1"/>
+          </p:cNvPicPr>
+          <p:nvPr/>
+        </p:nvPicPr>
+        <p:blipFill>
+          <a:blip r:embed="rId2">
+            <a:extLst>
+              <a:ext uri="{28A0092B-C50C-407E-A947-70E740481C1C}">
+                <a14:useLocalDpi xmlns:a14="http://schemas.microsoft.com/office/drawing/2010/main" val="0"/>
+              </a:ext>
+            </a:extLst>
+          </a:blip>
+          <a:srcRect r="6631"/>
+          <a:stretch>
+            <a:fillRect/>
+          </a:stretch>
+        </p:blipFill>
+        <p:spPr>
+          <a:xfrm>
+            <a:off x="6096000" y="284328"/>
+            <a:ext cx="4647945" cy="6379116"/>
+          </a:xfrm>
+          <a:prstGeom prst="rect">
+            <a:avLst/>
+          </a:prstGeom>
+          <a:ln>
+            <a:solidFill>
+              <a:schemeClr val="tx1"/>
+            </a:solidFill>
+          </a:ln>
+        </p:spPr>
+      </p:pic>
+      <p:pic>
+        <p:nvPicPr>
+          <p:cNvPr id="3" name="Picture 2">
+            <a:extLst>
+              <a:ext uri="{FF2B5EF4-FFF2-40B4-BE49-F238E27FC236}">
+                <a16:creationId xmlns:a16="http://schemas.microsoft.com/office/drawing/2014/main" id="{D1677FBE-2194-1499-5E3E-B8030CCE11D8}"/>
+              </a:ext>
+            </a:extLst>
+          </p:cNvPr>
+          <p:cNvPicPr>
+            <a:picLocks noChangeAspect="1"/>
+          </p:cNvPicPr>
+          <p:nvPr/>
+        </p:nvPicPr>
+        <p:blipFill>
+          <a:blip r:embed="rId3">
+            <a:extLst>
+              <a:ext uri="{28A0092B-C50C-407E-A947-70E740481C1C}">
+                <a14:useLocalDpi xmlns:a14="http://schemas.microsoft.com/office/drawing/2010/main" val="0"/>
+              </a:ext>
+            </a:extLst>
+          </a:blip>
+          <a:srcRect l="4414" t="14404"/>
+          <a:stretch>
+            <a:fillRect/>
+          </a:stretch>
+        </p:blipFill>
+        <p:spPr>
+          <a:xfrm rot="5400000">
+            <a:off x="509329" y="1331725"/>
+            <a:ext cx="6379117" cy="4284326"/>
+          </a:xfrm>
+          <a:prstGeom prst="rect">
+            <a:avLst/>
+          </a:prstGeom>
+        </p:spPr>
+      </p:pic>
+      <p:sp>
+        <p:nvSpPr>
+          <p:cNvPr id="8" name="TextBox 7">
+            <a:extLst>
+              <a:ext uri="{FF2B5EF4-FFF2-40B4-BE49-F238E27FC236}">
+                <a16:creationId xmlns:a16="http://schemas.microsoft.com/office/drawing/2014/main" id="{D6CD3B42-78EA-52F7-2F1D-EF7016D4B77F}"/>
+              </a:ext>
+            </a:extLst>
+          </p:cNvPr>
+          <p:cNvSpPr txBox="1"/>
+          <p:nvPr/>
+        </p:nvSpPr>
+        <p:spPr>
+          <a:xfrm>
+            <a:off x="1981726" y="2330138"/>
+            <a:ext cx="1108893" cy="646331"/>
+          </a:xfrm>
+          <a:prstGeom prst="rect">
+            <a:avLst/>
+          </a:prstGeom>
+          <a:noFill/>
+          <a:ln>
+            <a:noFill/>
+          </a:ln>
+        </p:spPr>
+        <p:txBody>
+          <a:bodyPr wrap="none" rtlCol="0">
+            <a:spAutoFit/>
+          </a:bodyPr>
+          <a:lstStyle/>
+          <a:p>
+            <a:pPr algn="ctr"/>
+            <a:r>
+              <a:rPr lang="en-US" dirty="0"/>
+              <a:t>Not</a:t>
+            </a:r>
+          </a:p>
+          <a:p>
+            <a:pPr algn="ctr"/>
+            <a:r>
+              <a:rPr lang="en-US" dirty="0"/>
+              <a:t>Detected</a:t>
+            </a:r>
+          </a:p>
+        </p:txBody>
+      </p:sp>
+      <p:cxnSp>
+        <p:nvCxnSpPr>
+          <p:cNvPr id="10" name="Straight Arrow Connector 9">
+            <a:extLst>
+              <a:ext uri="{FF2B5EF4-FFF2-40B4-BE49-F238E27FC236}">
+                <a16:creationId xmlns:a16="http://schemas.microsoft.com/office/drawing/2014/main" id="{BAC9156C-1547-0A20-4B86-F12232777F49}"/>
+              </a:ext>
+            </a:extLst>
+          </p:cNvPr>
+          <p:cNvCxnSpPr>
+            <a:cxnSpLocks/>
+          </p:cNvCxnSpPr>
+          <p:nvPr/>
+        </p:nvCxnSpPr>
+        <p:spPr>
+          <a:xfrm>
+            <a:off x="2612346" y="2929230"/>
+            <a:ext cx="126124" cy="338958"/>
+          </a:xfrm>
+          <a:prstGeom prst="straightConnector1">
+            <a:avLst/>
+          </a:prstGeom>
+          <a:ln>
+            <a:solidFill>
+              <a:schemeClr val="tx1"/>
+            </a:solidFill>
+            <a:tailEnd type="triangle"/>
+          </a:ln>
+        </p:spPr>
+        <p:style>
+          <a:lnRef idx="2">
+            <a:schemeClr val="accent1"/>
+          </a:lnRef>
+          <a:fillRef idx="0">
+            <a:schemeClr val="accent1"/>
+          </a:fillRef>
+          <a:effectRef idx="1">
+            <a:schemeClr val="accent1"/>
+          </a:effectRef>
+          <a:fontRef idx="minor">
+            <a:schemeClr val="tx1"/>
+          </a:fontRef>
+        </p:style>
+      </p:cxnSp>
+    </p:spTree>
+    <p:extLst>
+      <p:ext uri="{BB962C8B-B14F-4D97-AF65-F5344CB8AC3E}">
+        <p14:creationId xmlns:p14="http://schemas.microsoft.com/office/powerpoint/2010/main" val="3616266358"/>
+      </p:ext>
+    </p:extLst>
+  </p:cSld>
+  <p:clrMapOvr>
+    <a:masterClrMapping/>
+  </p:clrMapOvr>
+</p:sld>
+</file>
+
 <file path=ppt/theme/theme1.xml><?xml version="1.0" encoding="utf-8"?>
 <a:theme xmlns:a="http://schemas.openxmlformats.org/drawingml/2006/main" name="Office Theme">
   <a:themeElements>

</xml_diff>

<commit_message>
Document Pure Sim - field and object
</commit_message>
<xml_diff>
--- a/docs/MonarchVision Images.pptx
+++ b/docs/MonarchVision Images.pptx
@@ -9,6 +9,8 @@
     <p:sldId id="257" r:id="rId3"/>
     <p:sldId id="258" r:id="rId4"/>
     <p:sldId id="259" r:id="rId5"/>
+    <p:sldId id="260" r:id="rId6"/>
+    <p:sldId id="261" r:id="rId7"/>
   </p:sldIdLst>
   <p:sldSz cx="12192000" cy="6858000"/>
   <p:notesSz cx="6858000" cy="9144000"/>
@@ -4377,6 +4379,355 @@
 </p:sld>
 </file>
 
+<file path=ppt/slides/slide5.xml><?xml version="1.0" encoding="utf-8"?>
+<p:sld xmlns:a="http://schemas.openxmlformats.org/drawingml/2006/main" xmlns:r="http://schemas.openxmlformats.org/officeDocument/2006/relationships" xmlns:p="http://schemas.openxmlformats.org/presentationml/2006/main">
+  <p:cSld>
+    <p:spTree>
+      <p:nvGrpSpPr>
+        <p:cNvPr id="1" name=""/>
+        <p:cNvGrpSpPr/>
+        <p:nvPr/>
+      </p:nvGrpSpPr>
+      <p:grpSpPr>
+        <a:xfrm>
+          <a:off x="0" y="0"/>
+          <a:ext cx="0" cy="0"/>
+          <a:chOff x="0" y="0"/>
+          <a:chExt cx="0" cy="0"/>
+        </a:xfrm>
+      </p:grpSpPr>
+      <p:pic>
+        <p:nvPicPr>
+          <p:cNvPr id="5" name="Picture 4">
+            <a:extLst>
+              <a:ext uri="{FF2B5EF4-FFF2-40B4-BE49-F238E27FC236}">
+                <a16:creationId xmlns:a16="http://schemas.microsoft.com/office/drawing/2014/main" id="{25F61F47-8922-B6CC-E844-7020BD906388}"/>
+              </a:ext>
+            </a:extLst>
+          </p:cNvPr>
+          <p:cNvPicPr>
+            <a:picLocks noChangeAspect="1"/>
+          </p:cNvPicPr>
+          <p:nvPr/>
+        </p:nvPicPr>
+        <p:blipFill>
+          <a:blip r:embed="rId2"/>
+          <a:srcRect b="1072"/>
+          <a:stretch>
+            <a:fillRect/>
+          </a:stretch>
+        </p:blipFill>
+        <p:spPr>
+          <a:xfrm>
+            <a:off x="746784" y="611883"/>
+            <a:ext cx="4911688" cy="4073630"/>
+          </a:xfrm>
+          <a:prstGeom prst="rect">
+            <a:avLst/>
+          </a:prstGeom>
+          <a:ln>
+            <a:solidFill>
+              <a:schemeClr val="tx1"/>
+            </a:solidFill>
+          </a:ln>
+        </p:spPr>
+      </p:pic>
+      <p:pic>
+        <p:nvPicPr>
+          <p:cNvPr id="7" name="Picture 6">
+            <a:extLst>
+              <a:ext uri="{FF2B5EF4-FFF2-40B4-BE49-F238E27FC236}">
+                <a16:creationId xmlns:a16="http://schemas.microsoft.com/office/drawing/2014/main" id="{09A47CDF-3168-F308-D050-9ADA68AD9EA8}"/>
+              </a:ext>
+            </a:extLst>
+          </p:cNvPr>
+          <p:cNvPicPr>
+            <a:picLocks noChangeAspect="1"/>
+          </p:cNvPicPr>
+          <p:nvPr/>
+        </p:nvPicPr>
+        <p:blipFill>
+          <a:blip r:embed="rId3"/>
+          <a:stretch>
+            <a:fillRect/>
+          </a:stretch>
+        </p:blipFill>
+        <p:spPr>
+          <a:xfrm>
+            <a:off x="5816975" y="611882"/>
+            <a:ext cx="4899935" cy="4073630"/>
+          </a:xfrm>
+          <a:prstGeom prst="rect">
+            <a:avLst/>
+          </a:prstGeom>
+          <a:ln>
+            <a:solidFill>
+              <a:schemeClr val="tx1"/>
+            </a:solidFill>
+          </a:ln>
+        </p:spPr>
+      </p:pic>
+      <p:sp>
+        <p:nvSpPr>
+          <p:cNvPr id="8" name="TextBox 7">
+            <a:extLst>
+              <a:ext uri="{FF2B5EF4-FFF2-40B4-BE49-F238E27FC236}">
+                <a16:creationId xmlns:a16="http://schemas.microsoft.com/office/drawing/2014/main" id="{A05EC79A-B6E1-158B-374C-F8E6D3CE0A97}"/>
+              </a:ext>
+            </a:extLst>
+          </p:cNvPr>
+          <p:cNvSpPr txBox="1"/>
+          <p:nvPr/>
+        </p:nvSpPr>
+        <p:spPr>
+          <a:xfrm>
+            <a:off x="2176546" y="4841382"/>
+            <a:ext cx="2052165" cy="646331"/>
+          </a:xfrm>
+          <a:prstGeom prst="rect">
+            <a:avLst/>
+          </a:prstGeom>
+          <a:noFill/>
+        </p:spPr>
+        <p:txBody>
+          <a:bodyPr wrap="none" rtlCol="0">
+            <a:spAutoFit/>
+          </a:bodyPr>
+          <a:lstStyle/>
+          <a:p>
+            <a:pPr algn="ctr"/>
+            <a:r>
+              <a:rPr lang="en-US" dirty="0" err="1"/>
+              <a:t>front_camera</a:t>
+            </a:r>
+            <a:endParaRPr lang="en-US" dirty="0"/>
+          </a:p>
+          <a:p>
+            <a:pPr algn="ctr"/>
+            <a:r>
+              <a:rPr lang="en-US" dirty="0"/>
+              <a:t>192.168.4.80:1182</a:t>
+            </a:r>
+          </a:p>
+        </p:txBody>
+      </p:sp>
+      <p:sp>
+        <p:nvSpPr>
+          <p:cNvPr id="10" name="TextBox 9">
+            <a:extLst>
+              <a:ext uri="{FF2B5EF4-FFF2-40B4-BE49-F238E27FC236}">
+                <a16:creationId xmlns:a16="http://schemas.microsoft.com/office/drawing/2014/main" id="{474D761A-403D-9490-0B8D-CC22D4557AD4}"/>
+              </a:ext>
+            </a:extLst>
+          </p:cNvPr>
+          <p:cNvSpPr txBox="1"/>
+          <p:nvPr/>
+        </p:nvSpPr>
+        <p:spPr>
+          <a:xfrm>
+            <a:off x="7240860" y="4835075"/>
+            <a:ext cx="2052165" cy="646331"/>
+          </a:xfrm>
+          <a:prstGeom prst="rect">
+            <a:avLst/>
+          </a:prstGeom>
+          <a:noFill/>
+        </p:spPr>
+        <p:txBody>
+          <a:bodyPr wrap="none" rtlCol="0">
+            <a:spAutoFit/>
+          </a:bodyPr>
+          <a:lstStyle/>
+          <a:p>
+            <a:pPr algn="ctr"/>
+            <a:r>
+              <a:rPr lang="en-US" dirty="0" err="1"/>
+              <a:t>back_camera</a:t>
+            </a:r>
+            <a:endParaRPr lang="en-US" dirty="0"/>
+          </a:p>
+          <a:p>
+            <a:pPr algn="ctr"/>
+            <a:r>
+              <a:rPr lang="en-US" dirty="0"/>
+              <a:t>192.168.4.80:1184</a:t>
+            </a:r>
+          </a:p>
+        </p:txBody>
+      </p:sp>
+    </p:spTree>
+    <p:extLst>
+      <p:ext uri="{BB962C8B-B14F-4D97-AF65-F5344CB8AC3E}">
+        <p14:creationId xmlns:p14="http://schemas.microsoft.com/office/powerpoint/2010/main" val="350616676"/>
+      </p:ext>
+    </p:extLst>
+  </p:cSld>
+  <p:clrMapOvr>
+    <a:masterClrMapping/>
+  </p:clrMapOvr>
+</p:sld>
+</file>
+
+<file path=ppt/slides/slide6.xml><?xml version="1.0" encoding="utf-8"?>
+<p:sld xmlns:a="http://schemas.openxmlformats.org/drawingml/2006/main" xmlns:r="http://schemas.openxmlformats.org/officeDocument/2006/relationships" xmlns:p="http://schemas.openxmlformats.org/presentationml/2006/main">
+  <p:cSld>
+    <p:spTree>
+      <p:nvGrpSpPr>
+        <p:cNvPr id="1" name=""/>
+        <p:cNvGrpSpPr/>
+        <p:nvPr/>
+      </p:nvGrpSpPr>
+      <p:grpSpPr>
+        <a:xfrm>
+          <a:off x="0" y="0"/>
+          <a:ext cx="0" cy="0"/>
+          <a:chOff x="0" y="0"/>
+          <a:chExt cx="0" cy="0"/>
+        </a:xfrm>
+      </p:grpSpPr>
+      <p:pic>
+        <p:nvPicPr>
+          <p:cNvPr id="5" name="Picture 4">
+            <a:extLst>
+              <a:ext uri="{FF2B5EF4-FFF2-40B4-BE49-F238E27FC236}">
+                <a16:creationId xmlns:a16="http://schemas.microsoft.com/office/drawing/2014/main" id="{58719E5F-1C93-8324-3E14-232DF5FAB6BE}"/>
+              </a:ext>
+            </a:extLst>
+          </p:cNvPr>
+          <p:cNvPicPr>
+            <a:picLocks noChangeAspect="1"/>
+          </p:cNvPicPr>
+          <p:nvPr/>
+        </p:nvPicPr>
+        <p:blipFill>
+          <a:blip r:embed="rId2"/>
+          <a:stretch>
+            <a:fillRect/>
+          </a:stretch>
+        </p:blipFill>
+        <p:spPr>
+          <a:xfrm>
+            <a:off x="2330383" y="1371539"/>
+            <a:ext cx="3892720" cy="3514786"/>
+          </a:xfrm>
+          <a:prstGeom prst="rect">
+            <a:avLst/>
+          </a:prstGeom>
+        </p:spPr>
+      </p:pic>
+      <p:pic>
+        <p:nvPicPr>
+          <p:cNvPr id="7" name="Picture 6">
+            <a:extLst>
+              <a:ext uri="{FF2B5EF4-FFF2-40B4-BE49-F238E27FC236}">
+                <a16:creationId xmlns:a16="http://schemas.microsoft.com/office/drawing/2014/main" id="{80715B44-100F-9949-6133-41FC7F4BE6F2}"/>
+              </a:ext>
+            </a:extLst>
+          </p:cNvPr>
+          <p:cNvPicPr>
+            <a:picLocks noChangeAspect="1"/>
+          </p:cNvPicPr>
+          <p:nvPr/>
+        </p:nvPicPr>
+        <p:blipFill>
+          <a:blip r:embed="rId3"/>
+          <a:stretch>
+            <a:fillRect/>
+          </a:stretch>
+        </p:blipFill>
+        <p:spPr>
+          <a:xfrm>
+            <a:off x="6559483" y="1371539"/>
+            <a:ext cx="4215651" cy="3514786"/>
+          </a:xfrm>
+          <a:prstGeom prst="rect">
+            <a:avLst/>
+          </a:prstGeom>
+        </p:spPr>
+      </p:pic>
+      <p:sp>
+        <p:nvSpPr>
+          <p:cNvPr id="8" name="TextBox 7">
+            <a:extLst>
+              <a:ext uri="{FF2B5EF4-FFF2-40B4-BE49-F238E27FC236}">
+                <a16:creationId xmlns:a16="http://schemas.microsoft.com/office/drawing/2014/main" id="{975DA663-BD45-B4A8-5E98-1C97CAF13EE6}"/>
+              </a:ext>
+            </a:extLst>
+          </p:cNvPr>
+          <p:cNvSpPr txBox="1"/>
+          <p:nvPr/>
+        </p:nvSpPr>
+        <p:spPr>
+          <a:xfrm>
+            <a:off x="3356010" y="5117129"/>
+            <a:ext cx="1841466" cy="369332"/>
+          </a:xfrm>
+          <a:prstGeom prst="rect">
+            <a:avLst/>
+          </a:prstGeom>
+          <a:noFill/>
+        </p:spPr>
+        <p:txBody>
+          <a:bodyPr wrap="none" rtlCol="0">
+            <a:spAutoFit/>
+          </a:bodyPr>
+          <a:lstStyle/>
+          <a:p>
+            <a:r>
+              <a:rPr lang="en-US" dirty="0"/>
+              <a:t>No fuel detected</a:t>
+            </a:r>
+          </a:p>
+        </p:txBody>
+      </p:sp>
+      <p:sp>
+        <p:nvSpPr>
+          <p:cNvPr id="10" name="TextBox 9">
+            <a:extLst>
+              <a:ext uri="{FF2B5EF4-FFF2-40B4-BE49-F238E27FC236}">
+                <a16:creationId xmlns:a16="http://schemas.microsoft.com/office/drawing/2014/main" id="{A7104099-4C56-3DCE-563A-F4D26DA80FAD}"/>
+              </a:ext>
+            </a:extLst>
+          </p:cNvPr>
+          <p:cNvSpPr txBox="1"/>
+          <p:nvPr/>
+        </p:nvSpPr>
+        <p:spPr>
+          <a:xfrm>
+            <a:off x="7623945" y="5117129"/>
+            <a:ext cx="2086725" cy="369332"/>
+          </a:xfrm>
+          <a:prstGeom prst="rect">
+            <a:avLst/>
+          </a:prstGeom>
+          <a:noFill/>
+        </p:spPr>
+        <p:txBody>
+          <a:bodyPr wrap="none" rtlCol="0">
+            <a:spAutoFit/>
+          </a:bodyPr>
+          <a:lstStyle/>
+          <a:p>
+            <a:r>
+              <a:rPr lang="en-US" dirty="0"/>
+              <a:t>4 of 6 fuel detected</a:t>
+            </a:r>
+          </a:p>
+        </p:txBody>
+      </p:sp>
+    </p:spTree>
+    <p:extLst>
+      <p:ext uri="{BB962C8B-B14F-4D97-AF65-F5344CB8AC3E}">
+        <p14:creationId xmlns:p14="http://schemas.microsoft.com/office/powerpoint/2010/main" val="2657422718"/>
+      </p:ext>
+    </p:extLst>
+  </p:cSld>
+  <p:clrMapOvr>
+    <a:masterClrMapping/>
+  </p:clrMapOvr>
+</p:sld>
+</file>
+
 <file path=ppt/theme/theme1.xml><?xml version="1.0" encoding="utf-8"?>
 <a:theme xmlns:a="http://schemas.openxmlformats.org/drawingml/2006/main" name="Office Theme">
   <a:themeElements>

</xml_diff>